<commit_message>
docs: replace harness framing with document-driven workflow
</commit_message>
<xml_diff>
--- a/docs/ai-game-dev-guidelines-team-one-page.pptx
+++ b/docs/ai-game-dev-guidelines-team-one-page.pptx
@@ -170,7 +170,7 @@
             <a:pPr algn="ctr"/>
             <a:r>
               <a:rPr lang="ko-KR" sz="1600"/>
-              <a:t>차이는 문제를 무엇을 기준으로 수정하느냐에 있다</a:t>
+              <a:t>둘 다 같은 기본 작업 흐름을 따른다</a:t>
             </a:r>
             <a:endParaRPr lang="ko-KR" sz="1600"/>
           </a:p>
@@ -275,7 +275,7 @@
             <a:pPr algn="l"/>
             <a:r>
               <a:rPr lang="ko-KR" sz="1800"/>
-              <a:t>• 둘 다 비슷한 기본 작업 흐름을 따른다</a:t>
+              <a:t>• 둘 다 같은 기본 작업 흐름을 따른다</a:t>
             </a:r>
             <a:endParaRPr lang="ko-KR" sz="1800"/>
           </a:p>
@@ -283,7 +283,7 @@
             <a:pPr algn="l"/>
             <a:r>
               <a:rPr lang="ko-KR" sz="1800"/>
-              <a:t>• 차이는 문제가 생겼을 때 무엇을 기준으로 수정하느냐다</a:t>
+              <a:t>• 차이는 무엇을 기준으로 수정하느냐다</a:t>
             </a:r>
             <a:endParaRPr lang="ko-KR" sz="1800"/>
           </a:p>
@@ -291,7 +291,7 @@
             <a:pPr algn="l"/>
             <a:r>
               <a:rPr lang="ko-KR" sz="1800"/>
-              <a:t>• A는 문서와 하네스 기준, B는 코드와 구조 기준으로 수정한다</a:t>
+              <a:t>• A는 문서 기준, B는 코드와 구조 기준으로 수정한다</a:t>
             </a:r>
             <a:endParaRPr lang="ko-KR" sz="1800"/>
           </a:p>
@@ -438,7 +438,7 @@
             <a:pPr algn="l"/>
             <a:r>
               <a:rPr lang="ko-KR" sz="1600"/>
-              <a:t>• 시나리오와 하네스를 고쳐 다시 볼 생각일 때</a:t>
+              <a:t>• 문서와 시나리오를 고쳐 다시 볼 생각일 때</a:t>
             </a:r>
             <a:endParaRPr lang="ko-KR" sz="1600"/>
           </a:p>
@@ -617,7 +617,7 @@
             <a:pPr algn="l"/>
             <a:r>
               <a:rPr lang="ko-KR" sz="1800" b="1"/>
-              <a:t>1. 요구사항 / 개발 계획 정리</a:t>
+              <a:t>1. 요구사항 / 개발 계획을 md로 정리</a:t>
             </a:r>
             <a:endParaRPr lang="ko-KR" sz="1800" b="1"/>
           </a:p>
@@ -625,7 +625,7 @@
             <a:pPr algn="l"/>
             <a:r>
               <a:rPr lang="ko-KR" sz="1800" b="1"/>
-              <a:t>2. 작은 단위 구현</a:t>
+              <a:t>2. md 기준으로 작은 단위 구현</a:t>
             </a:r>
             <a:endParaRPr lang="ko-KR" sz="1800" b="1"/>
           </a:p>
@@ -633,7 +633,7 @@
             <a:pPr algn="l"/>
             <a:r>
               <a:rPr lang="ko-KR" sz="1800" b="1"/>
-              <a:t>3. AI 리뷰 + 인간 리뷰</a:t>
+              <a:t>3. AI 리뷰, 인간 리뷰, 테스트 진행</a:t>
             </a:r>
             <a:endParaRPr lang="ko-KR" sz="1800" b="1"/>
           </a:p>
@@ -641,23 +641,7 @@
             <a:pPr algn="l"/>
             <a:r>
               <a:rPr lang="ko-KR" sz="1800" b="1"/>
-              <a:t>4. 테스트 준비</a:t>
-            </a:r>
-            <a:endParaRPr lang="ko-KR" sz="1800" b="1"/>
-          </a:p>
-          <a:p>
-            <a:pPr algn="l"/>
-            <a:r>
-              <a:rPr lang="ko-KR" sz="1800" b="1"/>
-              <a:t>5. 실제 테스트</a:t>
-            </a:r>
-            <a:endParaRPr lang="ko-KR" sz="1800" b="1"/>
-          </a:p>
-          <a:p>
-            <a:pPr algn="l"/>
-            <a:r>
-              <a:rPr lang="ko-KR" sz="1800" b="1"/>
-              <a:t>6. 문제 수정 후 반복</a:t>
+              <a:t>4. 수정사항 정리 후 다시 1번으로</a:t>
             </a:r>
             <a:endParaRPr lang="ko-KR" sz="1800" b="1"/>
           </a:p>
@@ -714,7 +698,7 @@
             <a:pPr algn="l"/>
             <a:r>
               <a:rPr lang="ko-KR" sz="2400" b="1"/>
-              <a:t>문제 수정 방식의 차이</a:t>
+              <a:t>수정하는 기준의 차이</a:t>
             </a:r>
             <a:endParaRPr lang="ko-KR" sz="2400" b="1"/>
           </a:p>
@@ -748,7 +732,7 @@
             <a:pPr algn="l"/>
             <a:r>
               <a:rPr lang="ko-KR" sz="1800" b="1"/>
-              <a:t>A: 문서와 하네스 기준</a:t>
+              <a:t>A: 문서를 수정하면서 검증</a:t>
             </a:r>
             <a:endParaRPr lang="ko-KR" sz="1800" b="1"/>
           </a:p>
@@ -780,31 +764,31 @@
             <a:pPr algn="l"/>
             <a:r>
               <a:rPr lang="ko-KR" sz="1600"/>
-              <a:t>• 요구사항이 모호한지 본다</a:t>
-            </a:r>
-            <a:endParaRPr lang="ko-KR" sz="1600"/>
-          </a:p>
-          <a:p>
-            <a:pPr algn="l"/>
-            <a:r>
-              <a:rPr lang="ko-KR" sz="1600"/>
-              <a:t>• 검증 시나리오가 부족한지 본다</a:t>
-            </a:r>
-            <a:endParaRPr lang="ko-KR" sz="1600"/>
-          </a:p>
-          <a:p>
-            <a:pPr algn="l"/>
-            <a:r>
-              <a:rPr lang="ko-KR" sz="1600"/>
-              <a:t>• mock / stub / 입력값을 조정한다</a:t>
-            </a:r>
-            <a:endParaRPr lang="ko-KR" sz="1600"/>
-          </a:p>
-          <a:p>
-            <a:pPr algn="l"/>
-            <a:r>
-              <a:rPr lang="ko-KR" sz="1600"/>
-              <a:t>• 다시 실행해서 결과를 확인한다</a:t>
+              <a:t>• 요구사항과 계획을 다시 본다</a:t>
+            </a:r>
+            <a:endParaRPr lang="ko-KR" sz="1600"/>
+          </a:p>
+          <a:p>
+            <a:pPr algn="l"/>
+            <a:r>
+              <a:rPr lang="ko-KR" sz="1600"/>
+              <a:t>• 테스트 시나리오를 다시 정리한다</a:t>
+            </a:r>
+            <a:endParaRPr lang="ko-KR" sz="1600"/>
+          </a:p>
+          <a:p>
+            <a:pPr algn="l"/>
+            <a:r>
+              <a:rPr lang="ko-KR" sz="1600"/>
+              <a:t>• 테스트용 데이터와 입력값을 조정한다</a:t>
+            </a:r>
+            <a:endParaRPr lang="ko-KR" sz="1600"/>
+          </a:p>
+          <a:p>
+            <a:pPr algn="l"/>
+            <a:r>
+              <a:rPr lang="ko-KR" sz="1600"/>
+              <a:t>• 문서를 고치고 다시 구현한다</a:t>
             </a:r>
             <a:endParaRPr lang="ko-KR" sz="1600"/>
           </a:p>
@@ -838,7 +822,7 @@
             <a:pPr algn="l"/>
             <a:r>
               <a:rPr lang="ko-KR" sz="1800" b="1"/>
-              <a:t>B: 코드와 구조 기준</a:t>
+              <a:t>B: 코드와 구조를 수정하며 편입</a:t>
             </a:r>
             <a:endParaRPr lang="ko-KR" sz="1800" b="1"/>
           </a:p>
@@ -870,31 +854,31 @@
             <a:pPr algn="l"/>
             <a:r>
               <a:rPr lang="ko-KR" sz="1600"/>
-              <a:t>• 어떤 코드 경로에서 문제 나는지 본다</a:t>
-            </a:r>
-            <a:endParaRPr lang="ko-KR" sz="1600"/>
-          </a:p>
-          <a:p>
-            <a:pPr algn="l"/>
-            <a:r>
-              <a:rPr lang="ko-KR" sz="1600"/>
-              <a:t>• 구조, 책임 분리, 상태 전이를 점검한다</a:t>
-            </a:r>
-            <a:endParaRPr lang="ko-KR" sz="1600"/>
-          </a:p>
-          <a:p>
-            <a:pPr algn="l"/>
-            <a:r>
-              <a:rPr lang="ko-KR" sz="1600"/>
-              <a:t>• 코드 패치와 테스트 보강을 한다</a:t>
-            </a:r>
-            <a:endParaRPr lang="ko-KR" sz="1600"/>
-          </a:p>
-          <a:p>
-            <a:pPr algn="l"/>
-            <a:r>
-              <a:rPr lang="ko-KR" sz="1600"/>
-              <a:t>• 리뷰 후 다시 검증한다</a:t>
+              <a:t>• 문제 코드 경로와 상태 전이를 찾는다</a:t>
+            </a:r>
+            <a:endParaRPr lang="ko-KR" sz="1600"/>
+          </a:p>
+          <a:p>
+            <a:pPr algn="l"/>
+            <a:r>
+              <a:rPr lang="ko-KR" sz="1600"/>
+              <a:t>• 구조와 책임 분리를 다시 본다</a:t>
+            </a:r>
+            <a:endParaRPr lang="ko-KR" sz="1600"/>
+          </a:p>
+          <a:p>
+            <a:pPr algn="l"/>
+            <a:r>
+              <a:rPr lang="ko-KR" sz="1600"/>
+              <a:t>• 코드와 문서를 함께 수정한다</a:t>
+            </a:r>
+            <a:endParaRPr lang="ko-KR" sz="1600"/>
+          </a:p>
+          <a:p>
+            <a:pPr algn="l"/>
+            <a:r>
+              <a:rPr lang="ko-KR" sz="1600"/>
+              <a:t>• 리뷰와 테스트 후 다시 검증한다</a:t>
             </a:r>
             <a:endParaRPr lang="ko-KR" sz="1600"/>
           </a:p>
@@ -983,7 +967,7 @@
             <a:pPr algn="l"/>
             <a:r>
               <a:rPr lang="ko-KR" sz="1800"/>
-              <a:t>• AI에게 큰 범위를 한 번에 맡기지 않는다</a:t>
+              <a:t>• B는 시작 전에 코드베이스 분석과 규칙 파악이 먼저다</a:t>
             </a:r>
             <a:endParaRPr lang="ko-KR" sz="1800"/>
           </a:p>
@@ -991,7 +975,7 @@
             <a:pPr algn="l"/>
             <a:r>
               <a:rPr lang="ko-KR" sz="1800"/>
-              <a:t>• 분석 / 계획 / 구현 / 리뷰 / 테스트를 나눠서 쓴다</a:t>
+              <a:t>• AI는 분석 / 문서 작성 / 구현 / 리뷰 / 테스트로 나눠서 쓴다</a:t>
             </a:r>
             <a:endParaRPr lang="ko-KR" sz="1800"/>
           </a:p>
@@ -999,15 +983,7 @@
             <a:pPr algn="l"/>
             <a:r>
               <a:rPr lang="ko-KR" sz="1800"/>
-              <a:t>• A와 B를 섞지 않는다</a:t>
-            </a:r>
-            <a:endParaRPr lang="ko-KR" sz="1800"/>
-          </a:p>
-          <a:p>
-            <a:pPr algn="l"/>
-            <a:r>
-              <a:rPr lang="ko-KR" sz="1800"/>
-              <a:t>• AI를 코드 생성기만이 아니라 분석과 문서화 도구로도 쓴다</a:t>
+              <a:t>• 큰 범위를 한 번에 맡기지 않는다</a:t>
             </a:r>
             <a:endParaRPr lang="ko-KR" sz="1800"/>
           </a:p>

</xml_diff>

<commit_message>
docs: add AI development philosophy and pair-programming guidance
</commit_message>
<xml_diff>
--- a/docs/ai-game-dev-guidelines-team-one-page.pptx
+++ b/docs/ai-game-dev-guidelines-team-one-page.pptx
@@ -170,7 +170,7 @@
             <a:pPr algn="ctr"/>
             <a:r>
               <a:rPr lang="ko-KR" sz="1600"/>
-              <a:t>둘 다 같은 기본 작업 흐름을 따른다</a:t>
+              <a:t>AI는 블랙박스 자동 구현 도구가 아니다</a:t>
             </a:r>
             <a:endParaRPr lang="ko-KR" sz="1600"/>
           </a:p>
@@ -227,7 +227,7 @@
             <a:pPr algn="l"/>
             <a:r>
               <a:rPr lang="ko-KR" sz="2400" b="1"/>
-              <a:t>핵심 요약</a:t>
+              <a:t>먼저 깔고 가야 할 생각</a:t>
             </a:r>
             <a:endParaRPr lang="ko-KR" sz="2400" b="1"/>
           </a:p>
@@ -258,24 +258,8 @@
           <a:p>
             <a:pPr algn="l"/>
             <a:r>
-              <a:rPr lang="ko-KR" sz="1800" b="1"/>
-              <a:t>• A: 빠르게 검증하는 방식</a:t>
-            </a:r>
-            <a:endParaRPr lang="ko-KR" sz="1800" b="1"/>
-          </a:p>
-          <a:p>
-            <a:pPr algn="l"/>
-            <a:r>
-              <a:rPr lang="ko-KR" sz="1800" b="1"/>
-              <a:t>• B: 메인 프로젝트에 편입하는 방식</a:t>
-            </a:r>
-            <a:endParaRPr lang="ko-KR" sz="1800" b="1"/>
-          </a:p>
-          <a:p>
-            <a:pPr algn="l"/>
-            <a:r>
               <a:rPr lang="ko-KR" sz="1800"/>
-              <a:t>• 둘 다 같은 기본 작업 흐름을 따른다</a:t>
+              <a:t>• AI 활용의 핵심은 내 지식베이스를 넓히는 데 있다</a:t>
             </a:r>
             <a:endParaRPr lang="ko-KR" sz="1800"/>
           </a:p>
@@ -283,7 +267,7 @@
             <a:pPr algn="l"/>
             <a:r>
               <a:rPr lang="ko-KR" sz="1800"/>
-              <a:t>• 차이는 무엇을 기준으로 수정하느냐다</a:t>
+              <a:t>• AI가 만든 내용은 가능한 한 내가 이해할 수 있어야 한다</a:t>
             </a:r>
             <a:endParaRPr lang="ko-KR" sz="1800"/>
           </a:p>
@@ -291,7 +275,15 @@
             <a:pPr algn="l"/>
             <a:r>
               <a:rPr lang="ko-KR" sz="1800"/>
-              <a:t>• A는 문서 기준, B는 코드와 구조 기준으로 수정한다</a:t>
+              <a:t>• B에서는 AI보다 직접 개발이 더 빠를 때도 있다</a:t>
+            </a:r>
+            <a:endParaRPr lang="ko-KR" sz="1800"/>
+          </a:p>
+          <a:p>
+            <a:pPr algn="l"/>
+            <a:r>
+              <a:rPr lang="ko-KR" sz="1800"/>
+              <a:t>• 그래도 장기적으로는 AI와 페어하게 개발하는 편이 유리하다</a:t>
             </a:r>
             <a:endParaRPr lang="ko-KR" sz="1800"/>
           </a:p>
@@ -991,7 +983,7 @@
             <a:pPr algn="l"/>
             <a:r>
               <a:rPr lang="ko-KR" sz="1800" b="1"/>
-              <a:t>• 팀에서 기억할 한 문장: A는 검증용, B는 편입용</a:t>
+              <a:t>• 팀에서 기억할 한 문장: AI는 지식베이스를 넓히는 페어 개발 도구다</a:t>
             </a:r>
             <a:endParaRPr lang="ko-KR" sz="1800" b="1"/>
           </a:p>

</xml_diff>